<commit_message>
refactor(style): shorten verbose slide titles and fix color contrast for maximum readability
</commit_message>
<xml_diff>
--- a/briefing/NVM_AI_OCP_NVM_Opportunities_Executive_v18_Comprehensive_Update_EN.pptx
+++ b/briefing/NVM_AI_OCP_NVM_Opportunities_Executive_v18_Comprehensive_Update_EN.pptx
@@ -3220,7 +3220,7 @@
                 </a:solidFill>
                 <a:latin typeface="Arial"/>
               </a:rPr>
-              <a:t>AI SoC and UCIe Repair Qualify as Strategic Sockets</a:t>
+              <a:t>AI SoC and UCIe Repair Strategy</a:t>
             </a:r>
           </a:p>
           <a:p>
@@ -3239,7 +3239,7 @@
                 </a:solidFill>
                 <a:latin typeface="Arial"/>
               </a:rPr>
-              <a:t>Lead Advanced Packaging Lane Remapping Before Mass Deployment</a:t>
+              <a:t>Lead 3D Packaging Lane Remapping</a:t>
             </a:r>
           </a:p>
         </p:txBody>
@@ -4675,7 +4675,7 @@
             <a:r>
               <a:rPr sz="950" b="1">
                 <a:solidFill>
-                  <a:srgbClr val="71ECE3"/>
+                  <a:srgbClr val="8A521E"/>
                 </a:solidFill>
                 <a:latin typeface="Consolas"/>
               </a:rPr>
@@ -4741,7 +4741,7 @@
             <a:r>
               <a:rPr sz="1750" b="1">
                 <a:solidFill>
-                  <a:srgbClr val="FFFFFF"/>
+                  <a:srgbClr val="0A2434"/>
                 </a:solidFill>
                 <a:latin typeface="Arial"/>
               </a:rPr>
@@ -4807,7 +4807,7 @@
             <a:r>
               <a:rPr sz="1050" b="1">
                 <a:solidFill>
-                  <a:srgbClr val="71ECE3"/>
+                  <a:srgbClr val="8A521E"/>
                 </a:solidFill>
                 <a:latin typeface="Consolas"/>
               </a:rPr>
@@ -4873,7 +4873,7 @@
             <a:r>
               <a:rPr sz="1200" b="0">
                 <a:solidFill>
-                  <a:srgbClr val="C8D9E0"/>
+                  <a:srgbClr val="2C4251"/>
                 </a:solidFill>
                 <a:latin typeface="Arial"/>
               </a:rPr>
@@ -4892,7 +4892,7 @@
             <a:r>
               <a:rPr sz="1200" b="0">
                 <a:solidFill>
-                  <a:srgbClr val="C8D9E0"/>
+                  <a:srgbClr val="2C4251"/>
                 </a:solidFill>
                 <a:latin typeface="Arial"/>
               </a:rPr>
@@ -4958,7 +4958,7 @@
             <a:r>
               <a:rPr sz="1050" b="1">
                 <a:solidFill>
-                  <a:srgbClr val="71ECE3"/>
+                  <a:srgbClr val="125E52"/>
                 </a:solidFill>
                 <a:latin typeface="Consolas"/>
               </a:rPr>
@@ -5024,7 +5024,7 @@
             <a:r>
               <a:rPr sz="1200" b="0">
                 <a:solidFill>
-                  <a:srgbClr val="C8D9E0"/>
+                  <a:srgbClr val="2C4251"/>
                 </a:solidFill>
                 <a:latin typeface="Arial"/>
               </a:rPr>
@@ -5043,7 +5043,7 @@
             <a:r>
               <a:rPr sz="1200" b="0">
                 <a:solidFill>
-                  <a:srgbClr val="C8D9E0"/>
+                  <a:srgbClr val="2C4251"/>
                 </a:solidFill>
                 <a:latin typeface="Arial"/>
               </a:rPr>
@@ -5149,7 +5149,7 @@
             <a:r>
               <a:rPr sz="1350" b="1">
                 <a:solidFill>
-                  <a:srgbClr val="0A2434"/>
+                  <a:srgbClr val="FFFFFF"/>
                 </a:solidFill>
                 <a:latin typeface="Arial"/>
               </a:rPr>
@@ -5327,13 +5327,13 @@
               </a:defRPr>
             </a:pPr>
             <a:r>
-              <a:rPr sz="980" b="1">
-                <a:solidFill>
-                  <a:srgbClr val="176B5C"/>
+              <a:rPr sz="900" b="1">
+                <a:solidFill>
+                  <a:srgbClr val="FFFFFF"/>
                 </a:solidFill>
                 <a:latin typeface="Consolas"/>
               </a:rPr>
-              <a:t>10 · STRATEGIC TARGET · OCP SERVICE ROOT</a:t>
+              <a:t>STRATEGIC TARGET</a:t>
             </a:r>
           </a:p>
         </p:txBody>
@@ -5399,7 +5399,7 @@
                 </a:solidFill>
                 <a:latin typeface="Arial"/>
               </a:rPr>
-              <a:t>OCP Service State Demands Hardware-Anchored RoT</a:t>
+              <a:t>OCP Service Demands Hardware RoT</a:t>
             </a:r>
           </a:p>
           <a:p>
@@ -5418,7 +5418,7 @@
                 </a:solidFill>
                 <a:latin typeface="Arial"/>
               </a:rPr>
-              <a:t>Elevate Commodity Logging to Caliptra-Compliant Silicon Security</a:t>
+              <a:t>Elevate Logging to Caliptra Silicon Security</a:t>
             </a:r>
           </a:p>
         </p:txBody>
@@ -6986,7 +6986,7 @@
             <a:r>
               <a:rPr sz="950" b="1">
                 <a:solidFill>
-                  <a:srgbClr val="176B5C"/>
+                  <a:srgbClr val="71ECE3"/>
                 </a:solidFill>
                 <a:latin typeface="Consolas"/>
               </a:rPr>
@@ -7052,7 +7052,7 @@
             <a:r>
               <a:rPr sz="1600" b="1">
                 <a:solidFill>
-                  <a:srgbClr val="0A2434"/>
+                  <a:srgbClr val="FFFFFF"/>
                 </a:solidFill>
                 <a:latin typeface="Arial"/>
               </a:rPr>
@@ -7118,11 +7118,11 @@
             <a:r>
               <a:rPr sz="1150" b="0">
                 <a:solidFill>
-                  <a:srgbClr val="385365"/>
+                  <a:srgbClr val="C8D9E0"/>
                 </a:solidFill>
                 <a:latin typeface="Arial"/>
               </a:rPr>
-              <a:t>Integrate AntiFuse OTP + SRAM PUF</a:t>
+              <a:t>• Integrate AntiFuse OTP + SRAM PUF into module ASIC</a:t>
             </a:r>
           </a:p>
           <a:p>
@@ -7137,11 +7137,11 @@
             <a:r>
               <a:rPr sz="1150" b="0">
                 <a:solidFill>
-                  <a:srgbClr val="385365"/>
+                  <a:srgbClr val="C8D9E0"/>
                 </a:solidFill>
                 <a:latin typeface="Arial"/>
               </a:rPr>
-              <a:t>Zero at rest: keys never stored physically</a:t>
+              <a:t>• Zero at rest: keys never stored physically on silicon</a:t>
             </a:r>
           </a:p>
           <a:p>
@@ -7156,11 +7156,11 @@
             <a:r>
               <a:rPr sz="1150" b="0">
                 <a:solidFill>
-                  <a:srgbClr val="385365"/>
+                  <a:srgbClr val="C8D9E0"/>
                 </a:solidFill>
                 <a:latin typeface="Arial"/>
               </a:rPr>
-              <a:t>Eliminate board-level EEPROM BOM &amp; attack surface</a:t>
+              <a:t>• Eliminate board-level EEPROM BOM &amp; physical attack surface</a:t>
             </a:r>
           </a:p>
           <a:p>
@@ -7175,11 +7175,11 @@
             <a:r>
               <a:rPr sz="1150" b="0">
                 <a:solidFill>
-                  <a:srgbClr val="385365"/>
+                  <a:srgbClr val="C8D9E0"/>
                 </a:solidFill>
                 <a:latin typeface="Arial"/>
               </a:rPr>
-              <a:t>Deliver NIST SP 800-193 firmware resilience out of the box</a:t>
+              <a:t>• Deliver NIST SP 800-193 firmware resilience out of the box</a:t>
             </a:r>
           </a:p>
         </p:txBody>
@@ -7262,6 +7262,12 @@
               <a:lnSpc>
                 <a:spcPct val="103000"/>
               </a:lnSpc>
+              <a:spcBef>
+                <a:spcPts val="0"/>
+              </a:spcBef>
+              <a:spcAft>
+                <a:spcPts val="0"/>
+              </a:spcAft>
               <a:buNone/>
               <a:defRPr sz="920" b="1">
                 <a:solidFill>
@@ -7273,15 +7279,13 @@
               </a:defRPr>
             </a:pPr>
             <a:r>
-              <a:rPr sz="920" b="1">
-                <a:solidFill>
-                  <a:srgbClr val="C78A4B"/>
+              <a:rPr sz="950" b="1">
+                <a:solidFill>
+                  <a:srgbClr val="71ECE3"/>
                 </a:solidFill>
                 <a:latin typeface="Consolas"/>
-                <a:ea typeface="Consolas"/>
-                <a:cs typeface="Consolas"/>
               </a:rPr>
-              <a:t>EVIDENCE CEILING</a:t>
+              <a:t>MARKET FORESIGHT</a:t>
             </a:r>
           </a:p>
         </p:txBody>
@@ -7341,13 +7345,13 @@
               </a:defRPr>
             </a:pPr>
             <a:r>
-              <a:rPr sz="1200" b="0">
-                <a:solidFill>
-                  <a:srgbClr val="385365"/>
+              <a:rPr sz="1250" b="0">
+                <a:solidFill>
+                  <a:srgbClr val="FFFFFF"/>
                 </a:solidFill>
                 <a:latin typeface="Arial"/>
               </a:rPr>
-              <a:t>Marketing must anticipate where security standards will land: commodity logging inevitably converges into Caliptra-anchored silicon trust</a:t>
+              <a:t>Marketing foresight: commodity logging will inevitably converge into Caliptra-anchored silicon trust</a:t>
             </a:r>
           </a:p>
         </p:txBody>
@@ -7377,7 +7381,7 @@
             </a:avLst>
           </a:prstGeom>
           <a:solidFill>
-            <a:srgbClr val="F7EFE6"/>
+            <a:srgbClr val="125E52"/>
           </a:solidFill>
           <a:ln w="0">
             <a:noFill/>
@@ -7693,7 +7697,7 @@
                 </a:solidFill>
                 <a:latin typeface="Arial"/>
               </a:rPr>
-              <a:t>Decision Requested: Authorize Five Production Qualifications</a:t>
+              <a:t>Decision Requested: Five Qualifications</a:t>
             </a:r>
           </a:p>
           <a:p>
@@ -7712,7 +7716,7 @@
                 </a:solidFill>
                 <a:latin typeface="Arial"/>
               </a:rPr>
-              <a:t>And Lead Two Strategic Pre-Standard Design Initiatives</a:t>
+              <a:t>And Two Strategic Architecture Initiatives</a:t>
             </a:r>
           </a:p>
         </p:txBody>
@@ -10436,7 +10440,7 @@
               </a:defRPr>
             </a:pPr>
             <a:r>
-              <a:rPr sz="3000" b="1">
+              <a:rPr sz="2800" b="1">
                 <a:solidFill>
                   <a:srgbClr val="0A2434"/>
                 </a:solidFill>
@@ -15828,13 +15832,13 @@
               </a:defRPr>
             </a:pPr>
             <a:r>
-              <a:rPr sz="2700" b="1">
+              <a:rPr sz="2800" b="1">
                 <a:solidFill>
                   <a:srgbClr val="0A2434"/>
                 </a:solidFill>
                 <a:latin typeface="Arial"/>
               </a:rPr>
-              <a:t>Persistent Semantics Are Explicit;</a:t>
+              <a:t>Persistent Semantics Are Explicit</a:t>
             </a:r>
           </a:p>
           <a:p>
@@ -15847,13 +15851,13 @@
               </a:spcAft>
             </a:pPr>
             <a:r>
-              <a:rPr sz="2700" b="1">
+              <a:rPr sz="2800" b="1">
                 <a:solidFill>
                   <a:srgbClr val="0A2434"/>
                 </a:solidFill>
                 <a:latin typeface="Arial"/>
               </a:rPr>
-              <a:t>Implementation Technology Remains Bounded</a:t>
+              <a:t>Implementation Remains Bounded</a:t>
             </a:r>
           </a:p>
         </p:txBody>
@@ -17899,13 +17903,13 @@
               </a:defRPr>
             </a:pPr>
             <a:r>
-              <a:rPr sz="2700" b="1">
+              <a:rPr sz="2800" b="1">
                 <a:solidFill>
                   <a:srgbClr val="0A2434"/>
                 </a:solidFill>
                 <a:latin typeface="Arial"/>
               </a:rPr>
-              <a:t>Before Selecting OTP, Name the Repair State</a:t>
+              <a:t>Name the Repair State and Authority</a:t>
             </a:r>
           </a:p>
           <a:p>
@@ -17918,13 +17922,13 @@
               </a:spcAft>
             </a:pPr>
             <a:r>
-              <a:rPr sz="2700" b="1">
+              <a:rPr sz="2800" b="1">
                 <a:solidFill>
                   <a:srgbClr val="0A2434"/>
                 </a:solidFill>
                 <a:latin typeface="Arial"/>
               </a:rPr>
-              <a:t>and Its Programming Authority</a:t>
+              <a:t>Before Macro Selection</a:t>
             </a:r>
           </a:p>
         </p:txBody>
@@ -20255,7 +20259,7 @@
               </a:defRPr>
             </a:pPr>
             <a:r>
-              <a:rPr sz="3000" b="1">
+              <a:rPr sz="2800" b="1">
                 <a:solidFill>
                   <a:srgbClr val="0A2434"/>
                 </a:solidFill>
@@ -23744,7 +23748,7 @@
                 </a:solidFill>
                 <a:latin typeface="Arial"/>
               </a:rPr>
-              <a:t>Authorize Five Target-Bound Qualifications</a:t>
+              <a:t>Authorize Five Target Qualifications</a:t>
             </a:r>
           </a:p>
           <a:p>
@@ -23763,7 +23767,7 @@
                 </a:solidFill>
                 <a:latin typeface="Arial"/>
               </a:rPr>
-              <a:t>Advance UCIe Repair and OCP Caliptra Sockets</a:t>
+              <a:t>Advance UCIe Repair and OCP RoT</a:t>
             </a:r>
           </a:p>
         </p:txBody>
@@ -25985,7 +25989,7 @@
               </a:defRPr>
             </a:pPr>
             <a:r>
-              <a:rPr sz="3000" b="1">
+              <a:rPr sz="2800" b="1">
                 <a:solidFill>
                   <a:srgbClr val="0A2434"/>
                 </a:solidFill>
@@ -26004,7 +26008,7 @@
               </a:spcAft>
             </a:pPr>
             <a:r>
-              <a:rPr sz="3000" b="1">
+              <a:rPr sz="2800" b="1">
                 <a:solidFill>
                   <a:srgbClr val="0A2434"/>
                 </a:solidFill>
@@ -29428,7 +29432,7 @@
               </a:defRPr>
             </a:pPr>
             <a:r>
-              <a:rPr sz="3000" b="1">
+              <a:rPr sz="2800" b="1">
                 <a:solidFill>
                   <a:srgbClr val="0A2434"/>
                 </a:solidFill>
@@ -29447,7 +29451,7 @@
               </a:spcAft>
             </a:pPr>
             <a:r>
-              <a:rPr sz="3000" b="1">
+              <a:rPr sz="2800" b="1">
                 <a:solidFill>
                   <a:srgbClr val="0A2434"/>
                 </a:solidFill>
@@ -31454,7 +31458,7 @@
               </a:defRPr>
             </a:pPr>
             <a:r>
-              <a:rPr sz="3000" b="1">
+              <a:rPr sz="2800" b="1">
                 <a:solidFill>
                   <a:srgbClr val="0A2434"/>
                 </a:solidFill>
@@ -31473,7 +31477,7 @@
               </a:spcAft>
             </a:pPr>
             <a:r>
-              <a:rPr sz="3000" b="1">
+              <a:rPr sz="2800" b="1">
                 <a:solidFill>
                   <a:srgbClr val="0A2434"/>
                 </a:solidFill>
@@ -33864,7 +33868,7 @@
               </a:defRPr>
             </a:pPr>
             <a:r>
-              <a:rPr sz="2700" b="1">
+              <a:rPr sz="2800" b="1">
                 <a:solidFill>
                   <a:srgbClr val="0A2434"/>
                 </a:solidFill>
@@ -33883,7 +33887,7 @@
               </a:spcAft>
             </a:pPr>
             <a:r>
-              <a:rPr sz="2700" b="1">
+              <a:rPr sz="2800" b="1">
                 <a:solidFill>
                   <a:srgbClr val="0A2434"/>
                 </a:solidFill>
@@ -36915,7 +36919,7 @@
               </a:defRPr>
             </a:pPr>
             <a:r>
-              <a:rPr sz="3000" b="1">
+              <a:rPr sz="2800" b="1">
                 <a:solidFill>
                   <a:srgbClr val="0A2434"/>
                 </a:solidFill>
@@ -36934,7 +36938,7 @@
               </a:spcAft>
             </a:pPr>
             <a:r>
-              <a:rPr sz="3000" b="1">
+              <a:rPr sz="2800" b="1">
                 <a:solidFill>
                   <a:srgbClr val="0A2434"/>
                 </a:solidFill>
@@ -38988,7 +38992,7 @@
               </a:defRPr>
             </a:pPr>
             <a:r>
-              <a:rPr sz="3000" b="1">
+              <a:rPr sz="2800" b="1">
                 <a:solidFill>
                   <a:srgbClr val="0A2434"/>
                 </a:solidFill>
@@ -39007,7 +39011,7 @@
               </a:spcAft>
             </a:pPr>
             <a:r>
-              <a:rPr sz="3000" b="1">
+              <a:rPr sz="2800" b="1">
                 <a:solidFill>
                   <a:srgbClr val="0A2434"/>
                 </a:solidFill>
@@ -41061,7 +41065,7 @@
               </a:defRPr>
             </a:pPr>
             <a:r>
-              <a:rPr sz="3000" b="1">
+              <a:rPr sz="2800" b="1">
                 <a:solidFill>
                   <a:srgbClr val="0A2434"/>
                 </a:solidFill>
@@ -41080,7 +41084,7 @@
               </a:spcAft>
             </a:pPr>
             <a:r>
-              <a:rPr sz="3000" b="1">
+              <a:rPr sz="2800" b="1">
                 <a:solidFill>
                   <a:srgbClr val="0A2434"/>
                 </a:solidFill>

</xml_diff>